<commit_message>
Move flowchart Yes/No labels next to their arrows; keep local wording edit
</commit_message>
<xml_diff>
--- a/docs/week3/workflow-v1.pptx
+++ b/docs/week3/workflow-v1.pptx
@@ -1988,7 +1988,7 @@
         </p:nvSpPr>
         <p:spPr>
           <a:xfrm>
-            <a:off x="5943600" y="1051560"/>
+            <a:off x="5943600" y="1581912"/>
             <a:ext cx="365760" cy="228600"/>
           </a:xfrm>
           <a:prstGeom prst="rect">
@@ -2051,7 +2051,7 @@
         </p:nvSpPr>
         <p:spPr>
           <a:xfrm>
-            <a:off x="7909560" y="1051560"/>
+            <a:off x="7909560" y="1581912"/>
             <a:ext cx="365760" cy="228600"/>
           </a:xfrm>
           <a:prstGeom prst="rect">
@@ -2280,8 +2280,8 @@
         </p:nvSpPr>
         <p:spPr>
           <a:xfrm>
-            <a:off x="3063240" y="2404872"/>
-            <a:ext cx="1645920" cy="228600"/>
+            <a:off x="5216652" y="2404872"/>
+            <a:ext cx="548640" cy="228600"/>
           </a:xfrm>
           <a:prstGeom prst="rect">
             <a:avLst/>
@@ -2343,8 +2343,8 @@
         </p:nvSpPr>
         <p:spPr>
           <a:xfrm>
-            <a:off x="7955280" y="2404872"/>
-            <a:ext cx="1645920" cy="228600"/>
+            <a:off x="7182612" y="2404872"/>
+            <a:ext cx="548640" cy="228600"/>
           </a:xfrm>
           <a:prstGeom prst="rect">
             <a:avLst/>

</xml_diff>